<commit_message>
Owner deck: add Somali translation
Co-Authored-By: Claude Sonnet 5.5 <noreply@anthropic.com>
Claude-Session: https://claude.ai/code/session_01JA5WsUYa1ui13ckGGVaXNQ
</commit_message>
<xml_diff>
--- a/docs/Salon_Owner_Summary.pptx
+++ b/docs/Salon_Owner_Summary.pptx
@@ -10,9 +10,14 @@
     <p:sldId id="258" r:id="rId4"/>
     <p:sldId id="259" r:id="rId5"/>
     <p:sldId id="260" r:id="rId6"/>
+    <p:sldId id="261" r:id="rId7"/>
+    <p:sldId id="262" r:id="rId8"/>
+    <p:sldId id="263" r:id="rId9"/>
+    <p:sldId id="264" r:id="rId10"/>
+    <p:sldId id="265" r:id="rId11"/>
   </p:sldIdLst>
   <p:notesMasterIdLst>
-    <p:notesMasterId r:id="rId7"/>
+    <p:notesMasterId r:id="rId12"/>
   </p:notesMasterIdLst>
   <p:sldSz cx="9144000" cy="5143500"/>
   <p:notesSz cx="5143500" cy="9144000"/>
@@ -548,6 +553,94 @@
 </p:notes>
 </file>
 
+<file path=ppt/notesSlides/notesSlide10.xml><?xml version="1.0" encoding="utf-8"?>
+<p:notes xmlns:a="http://schemas.openxmlformats.org/drawingml/2006/main" xmlns:r="http://schemas.openxmlformats.org/officeDocument/2006/relationships" xmlns:p="http://schemas.openxmlformats.org/presentationml/2006/main">
+  <p:cSld>
+    <p:spTree>
+      <p:nvGrpSpPr>
+        <p:cNvPr id="1" name=""/>
+        <p:cNvGrpSpPr/>
+        <p:nvPr/>
+      </p:nvGrpSpPr>
+      <p:grpSpPr>
+        <a:xfrm>
+          <a:off x="0" y="0"/>
+          <a:ext cx="0" cy="0"/>
+          <a:chOff x="0" y="0"/>
+          <a:chExt cx="0" cy="0"/>
+        </a:xfrm>
+      </p:grpSpPr>
+      <p:sp>
+        <p:nvSpPr>
+          <p:cNvPr id="2" name="Slide Image Placeholder 1"/>
+          <p:cNvSpPr>
+            <a:spLocks noGrp="1" noRot="1" noChangeAspect="1"/>
+          </p:cNvSpPr>
+          <p:nvPr>
+            <p:ph type="sldImg"/>
+          </p:nvPr>
+        </p:nvSpPr>
+        <p:spPr/>
+      </p:sp>
+      <p:sp>
+        <p:nvSpPr>
+          <p:cNvPr id="3" name="Notes Placeholder 2"/>
+          <p:cNvSpPr>
+            <a:spLocks noGrp="1"/>
+          </p:cNvSpPr>
+          <p:nvPr>
+            <p:ph type="body" idx="1"/>
+          </p:nvPr>
+        </p:nvSpPr>
+        <p:spPr/>
+        <p:txBody>
+          <a:bodyPr/>
+          <a:lstStyle/>
+          <a:p>
+            <a:r>
+              <a:rPr lang="en-US" dirty="0"/>
+              <a:t/>
+            </a:r>
+            <a:endParaRPr lang="en-US" dirty="0"/>
+          </a:p>
+        </p:txBody>
+      </p:sp>
+      <p:sp>
+        <p:nvSpPr>
+          <p:cNvPr id="4" name="Slide Number Placeholder 3"/>
+          <p:cNvSpPr>
+            <a:spLocks noGrp="1"/>
+          </p:cNvSpPr>
+          <p:nvPr>
+            <p:ph type="sldNum" sz="quarter" idx="10"/>
+          </p:nvPr>
+        </p:nvSpPr>
+        <p:spPr/>
+        <p:txBody>
+          <a:bodyPr/>
+          <a:lstStyle/>
+          <a:p>
+            <a:fld id="{F7021451-1387-4CA6-816F-3879F97B5CBC}" type="slidenum">
+              <a:rPr lang="en-US"/>
+              <a:t>10</a:t>
+            </a:fld>
+            <a:endParaRPr lang="en-US"/>
+          </a:p>
+        </p:txBody>
+      </p:sp>
+    </p:spTree>
+    <p:extLst>
+      <p:ext uri="{BB962C8B-B14F-4D97-AF65-F5344CB8AC3E}">
+        <p14:creationId xmlns:p14="http://schemas.microsoft.com/office/powerpoint/2010/main" val="1024086991"/>
+      </p:ext>
+    </p:extLst>
+  </p:cSld>
+  <p:clrMapOvr>
+    <a:masterClrMapping/>
+  </p:clrMapOvr>
+</p:notes>
+</file>
+
 <file path=ppt/notesSlides/notesSlide2.xml><?xml version="1.0" encoding="utf-8"?>
 <p:notes xmlns:a="http://schemas.openxmlformats.org/drawingml/2006/main" xmlns:r="http://schemas.openxmlformats.org/officeDocument/2006/relationships" xmlns:p="http://schemas.openxmlformats.org/presentationml/2006/main">
   <p:cSld>
@@ -882,6 +975,358 @@
             <a:fld id="{F7021451-1387-4CA6-816F-3879F97B5CBC}" type="slidenum">
               <a:rPr lang="en-US"/>
               <a:t>5</a:t>
+            </a:fld>
+            <a:endParaRPr lang="en-US"/>
+          </a:p>
+        </p:txBody>
+      </p:sp>
+    </p:spTree>
+    <p:extLst>
+      <p:ext uri="{BB962C8B-B14F-4D97-AF65-F5344CB8AC3E}">
+        <p14:creationId xmlns:p14="http://schemas.microsoft.com/office/powerpoint/2010/main" val="1024086991"/>
+      </p:ext>
+    </p:extLst>
+  </p:cSld>
+  <p:clrMapOvr>
+    <a:masterClrMapping/>
+  </p:clrMapOvr>
+</p:notes>
+</file>
+
+<file path=ppt/notesSlides/notesSlide6.xml><?xml version="1.0" encoding="utf-8"?>
+<p:notes xmlns:a="http://schemas.openxmlformats.org/drawingml/2006/main" xmlns:r="http://schemas.openxmlformats.org/officeDocument/2006/relationships" xmlns:p="http://schemas.openxmlformats.org/presentationml/2006/main">
+  <p:cSld>
+    <p:spTree>
+      <p:nvGrpSpPr>
+        <p:cNvPr id="1" name=""/>
+        <p:cNvGrpSpPr/>
+        <p:nvPr/>
+      </p:nvGrpSpPr>
+      <p:grpSpPr>
+        <a:xfrm>
+          <a:off x="0" y="0"/>
+          <a:ext cx="0" cy="0"/>
+          <a:chOff x="0" y="0"/>
+          <a:chExt cx="0" cy="0"/>
+        </a:xfrm>
+      </p:grpSpPr>
+      <p:sp>
+        <p:nvSpPr>
+          <p:cNvPr id="2" name="Slide Image Placeholder 1"/>
+          <p:cNvSpPr>
+            <a:spLocks noGrp="1" noRot="1" noChangeAspect="1"/>
+          </p:cNvSpPr>
+          <p:nvPr>
+            <p:ph type="sldImg"/>
+          </p:nvPr>
+        </p:nvSpPr>
+        <p:spPr/>
+      </p:sp>
+      <p:sp>
+        <p:nvSpPr>
+          <p:cNvPr id="3" name="Notes Placeholder 2"/>
+          <p:cNvSpPr>
+            <a:spLocks noGrp="1"/>
+          </p:cNvSpPr>
+          <p:nvPr>
+            <p:ph type="body" idx="1"/>
+          </p:nvPr>
+        </p:nvSpPr>
+        <p:spPr/>
+        <p:txBody>
+          <a:bodyPr/>
+          <a:lstStyle/>
+          <a:p>
+            <a:r>
+              <a:rPr lang="en-US" dirty="0"/>
+              <a:t/>
+            </a:r>
+            <a:endParaRPr lang="en-US" dirty="0"/>
+          </a:p>
+        </p:txBody>
+      </p:sp>
+      <p:sp>
+        <p:nvSpPr>
+          <p:cNvPr id="4" name="Slide Number Placeholder 3"/>
+          <p:cNvSpPr>
+            <a:spLocks noGrp="1"/>
+          </p:cNvSpPr>
+          <p:nvPr>
+            <p:ph type="sldNum" sz="quarter" idx="10"/>
+          </p:nvPr>
+        </p:nvSpPr>
+        <p:spPr/>
+        <p:txBody>
+          <a:bodyPr/>
+          <a:lstStyle/>
+          <a:p>
+            <a:fld id="{F7021451-1387-4CA6-816F-3879F97B5CBC}" type="slidenum">
+              <a:rPr lang="en-US"/>
+              <a:t>6</a:t>
+            </a:fld>
+            <a:endParaRPr lang="en-US"/>
+          </a:p>
+        </p:txBody>
+      </p:sp>
+    </p:spTree>
+    <p:extLst>
+      <p:ext uri="{BB962C8B-B14F-4D97-AF65-F5344CB8AC3E}">
+        <p14:creationId xmlns:p14="http://schemas.microsoft.com/office/powerpoint/2010/main" val="1024086991"/>
+      </p:ext>
+    </p:extLst>
+  </p:cSld>
+  <p:clrMapOvr>
+    <a:masterClrMapping/>
+  </p:clrMapOvr>
+</p:notes>
+</file>
+
+<file path=ppt/notesSlides/notesSlide7.xml><?xml version="1.0" encoding="utf-8"?>
+<p:notes xmlns:a="http://schemas.openxmlformats.org/drawingml/2006/main" xmlns:r="http://schemas.openxmlformats.org/officeDocument/2006/relationships" xmlns:p="http://schemas.openxmlformats.org/presentationml/2006/main">
+  <p:cSld>
+    <p:spTree>
+      <p:nvGrpSpPr>
+        <p:cNvPr id="1" name=""/>
+        <p:cNvGrpSpPr/>
+        <p:nvPr/>
+      </p:nvGrpSpPr>
+      <p:grpSpPr>
+        <a:xfrm>
+          <a:off x="0" y="0"/>
+          <a:ext cx="0" cy="0"/>
+          <a:chOff x="0" y="0"/>
+          <a:chExt cx="0" cy="0"/>
+        </a:xfrm>
+      </p:grpSpPr>
+      <p:sp>
+        <p:nvSpPr>
+          <p:cNvPr id="2" name="Slide Image Placeholder 1"/>
+          <p:cNvSpPr>
+            <a:spLocks noGrp="1" noRot="1" noChangeAspect="1"/>
+          </p:cNvSpPr>
+          <p:nvPr>
+            <p:ph type="sldImg"/>
+          </p:nvPr>
+        </p:nvSpPr>
+        <p:spPr/>
+      </p:sp>
+      <p:sp>
+        <p:nvSpPr>
+          <p:cNvPr id="3" name="Notes Placeholder 2"/>
+          <p:cNvSpPr>
+            <a:spLocks noGrp="1"/>
+          </p:cNvSpPr>
+          <p:nvPr>
+            <p:ph type="body" idx="1"/>
+          </p:nvPr>
+        </p:nvSpPr>
+        <p:spPr/>
+        <p:txBody>
+          <a:bodyPr/>
+          <a:lstStyle/>
+          <a:p>
+            <a:r>
+              <a:rPr lang="en-US" dirty="0"/>
+              <a:t/>
+            </a:r>
+            <a:endParaRPr lang="en-US" dirty="0"/>
+          </a:p>
+        </p:txBody>
+      </p:sp>
+      <p:sp>
+        <p:nvSpPr>
+          <p:cNvPr id="4" name="Slide Number Placeholder 3"/>
+          <p:cNvSpPr>
+            <a:spLocks noGrp="1"/>
+          </p:cNvSpPr>
+          <p:nvPr>
+            <p:ph type="sldNum" sz="quarter" idx="10"/>
+          </p:nvPr>
+        </p:nvSpPr>
+        <p:spPr/>
+        <p:txBody>
+          <a:bodyPr/>
+          <a:lstStyle/>
+          <a:p>
+            <a:fld id="{F7021451-1387-4CA6-816F-3879F97B5CBC}" type="slidenum">
+              <a:rPr lang="en-US"/>
+              <a:t>7</a:t>
+            </a:fld>
+            <a:endParaRPr lang="en-US"/>
+          </a:p>
+        </p:txBody>
+      </p:sp>
+    </p:spTree>
+    <p:extLst>
+      <p:ext uri="{BB962C8B-B14F-4D97-AF65-F5344CB8AC3E}">
+        <p14:creationId xmlns:p14="http://schemas.microsoft.com/office/powerpoint/2010/main" val="1024086991"/>
+      </p:ext>
+    </p:extLst>
+  </p:cSld>
+  <p:clrMapOvr>
+    <a:masterClrMapping/>
+  </p:clrMapOvr>
+</p:notes>
+</file>
+
+<file path=ppt/notesSlides/notesSlide8.xml><?xml version="1.0" encoding="utf-8"?>
+<p:notes xmlns:a="http://schemas.openxmlformats.org/drawingml/2006/main" xmlns:r="http://schemas.openxmlformats.org/officeDocument/2006/relationships" xmlns:p="http://schemas.openxmlformats.org/presentationml/2006/main">
+  <p:cSld>
+    <p:spTree>
+      <p:nvGrpSpPr>
+        <p:cNvPr id="1" name=""/>
+        <p:cNvGrpSpPr/>
+        <p:nvPr/>
+      </p:nvGrpSpPr>
+      <p:grpSpPr>
+        <a:xfrm>
+          <a:off x="0" y="0"/>
+          <a:ext cx="0" cy="0"/>
+          <a:chOff x="0" y="0"/>
+          <a:chExt cx="0" cy="0"/>
+        </a:xfrm>
+      </p:grpSpPr>
+      <p:sp>
+        <p:nvSpPr>
+          <p:cNvPr id="2" name="Slide Image Placeholder 1"/>
+          <p:cNvSpPr>
+            <a:spLocks noGrp="1" noRot="1" noChangeAspect="1"/>
+          </p:cNvSpPr>
+          <p:nvPr>
+            <p:ph type="sldImg"/>
+          </p:nvPr>
+        </p:nvSpPr>
+        <p:spPr/>
+      </p:sp>
+      <p:sp>
+        <p:nvSpPr>
+          <p:cNvPr id="3" name="Notes Placeholder 2"/>
+          <p:cNvSpPr>
+            <a:spLocks noGrp="1"/>
+          </p:cNvSpPr>
+          <p:nvPr>
+            <p:ph type="body" idx="1"/>
+          </p:nvPr>
+        </p:nvSpPr>
+        <p:spPr/>
+        <p:txBody>
+          <a:bodyPr/>
+          <a:lstStyle/>
+          <a:p>
+            <a:r>
+              <a:rPr lang="en-US" dirty="0"/>
+              <a:t/>
+            </a:r>
+            <a:endParaRPr lang="en-US" dirty="0"/>
+          </a:p>
+        </p:txBody>
+      </p:sp>
+      <p:sp>
+        <p:nvSpPr>
+          <p:cNvPr id="4" name="Slide Number Placeholder 3"/>
+          <p:cNvSpPr>
+            <a:spLocks noGrp="1"/>
+          </p:cNvSpPr>
+          <p:nvPr>
+            <p:ph type="sldNum" sz="quarter" idx="10"/>
+          </p:nvPr>
+        </p:nvSpPr>
+        <p:spPr/>
+        <p:txBody>
+          <a:bodyPr/>
+          <a:lstStyle/>
+          <a:p>
+            <a:fld id="{F7021451-1387-4CA6-816F-3879F97B5CBC}" type="slidenum">
+              <a:rPr lang="en-US"/>
+              <a:t>8</a:t>
+            </a:fld>
+            <a:endParaRPr lang="en-US"/>
+          </a:p>
+        </p:txBody>
+      </p:sp>
+    </p:spTree>
+    <p:extLst>
+      <p:ext uri="{BB962C8B-B14F-4D97-AF65-F5344CB8AC3E}">
+        <p14:creationId xmlns:p14="http://schemas.microsoft.com/office/powerpoint/2010/main" val="1024086991"/>
+      </p:ext>
+    </p:extLst>
+  </p:cSld>
+  <p:clrMapOvr>
+    <a:masterClrMapping/>
+  </p:clrMapOvr>
+</p:notes>
+</file>
+
+<file path=ppt/notesSlides/notesSlide9.xml><?xml version="1.0" encoding="utf-8"?>
+<p:notes xmlns:a="http://schemas.openxmlformats.org/drawingml/2006/main" xmlns:r="http://schemas.openxmlformats.org/officeDocument/2006/relationships" xmlns:p="http://schemas.openxmlformats.org/presentationml/2006/main">
+  <p:cSld>
+    <p:spTree>
+      <p:nvGrpSpPr>
+        <p:cNvPr id="1" name=""/>
+        <p:cNvGrpSpPr/>
+        <p:nvPr/>
+      </p:nvGrpSpPr>
+      <p:grpSpPr>
+        <a:xfrm>
+          <a:off x="0" y="0"/>
+          <a:ext cx="0" cy="0"/>
+          <a:chOff x="0" y="0"/>
+          <a:chExt cx="0" cy="0"/>
+        </a:xfrm>
+      </p:grpSpPr>
+      <p:sp>
+        <p:nvSpPr>
+          <p:cNvPr id="2" name="Slide Image Placeholder 1"/>
+          <p:cNvSpPr>
+            <a:spLocks noGrp="1" noRot="1" noChangeAspect="1"/>
+          </p:cNvSpPr>
+          <p:nvPr>
+            <p:ph type="sldImg"/>
+          </p:nvPr>
+        </p:nvSpPr>
+        <p:spPr/>
+      </p:sp>
+      <p:sp>
+        <p:nvSpPr>
+          <p:cNvPr id="3" name="Notes Placeholder 2"/>
+          <p:cNvSpPr>
+            <a:spLocks noGrp="1"/>
+          </p:cNvSpPr>
+          <p:nvPr>
+            <p:ph type="body" idx="1"/>
+          </p:nvPr>
+        </p:nvSpPr>
+        <p:spPr/>
+        <p:txBody>
+          <a:bodyPr/>
+          <a:lstStyle/>
+          <a:p>
+            <a:r>
+              <a:rPr lang="en-US" dirty="0"/>
+              <a:t/>
+            </a:r>
+            <a:endParaRPr lang="en-US" dirty="0"/>
+          </a:p>
+        </p:txBody>
+      </p:sp>
+      <p:sp>
+        <p:nvSpPr>
+          <p:cNvPr id="4" name="Slide Number Placeholder 3"/>
+          <p:cNvSpPr>
+            <a:spLocks noGrp="1"/>
+          </p:cNvSpPr>
+          <p:nvPr>
+            <p:ph type="sldNum" sz="quarter" idx="10"/>
+          </p:nvPr>
+        </p:nvSpPr>
+        <p:spPr/>
+        <p:txBody>
+          <a:bodyPr/>
+          <a:lstStyle/>
+          <a:p>
+            <a:fld id="{F7021451-1387-4CA6-816F-3879F97B5CBC}" type="slidenum">
+              <a:rPr lang="en-US"/>
+              <a:t>9</a:t>
             </a:fld>
             <a:endParaRPr lang="en-US"/>
           </a:p>
@@ -1256,7 +1701,7 @@
               <a:buNone/>
             </a:pPr>
             <a:r>
-              <a:rPr lang="en-US" sz="4800" b="1" dirty="0">
+              <a:rPr lang="en-US" sz="4400" b="1" dirty="0">
                 <a:solidFill>
                   <a:srgbClr val="FFFFFF"/>
                 </a:solidFill>
@@ -1266,7 +1711,7 @@
               </a:rPr>
               <a:t>Your new salon system</a:t>
             </a:r>
-            <a:endParaRPr lang="en-US" sz="4800" dirty="0"/>
+            <a:endParaRPr lang="en-US" sz="4400" dirty="0"/>
           </a:p>
         </p:txBody>
       </p:sp>
@@ -1306,6 +1751,536 @@
               <a:t>What it does, whether it is safe, and what to arrange before opening day</a:t>
             </a:r>
             <a:endParaRPr lang="en-US" sz="2000" dirty="0"/>
+          </a:p>
+        </p:txBody>
+      </p:sp>
+      <p:sp>
+        <p:nvSpPr>
+          <p:cNvPr id="4" name="Text 2"/>
+          <p:cNvSpPr txBox="1"/>
+          <p:nvPr/>
+        </p:nvSpPr>
+        <p:spPr>
+          <a:xfrm>
+            <a:off x="640080" y="4297680"/>
+            <a:ext cx="3657600" cy="365760"/>
+          </a:xfrm>
+          <a:prstGeom prst="rect">
+            <a:avLst/>
+          </a:prstGeom>
+          <a:noFill/>
+          <a:ln/>
+        </p:spPr>
+        <p:txBody>
+          <a:bodyPr wrap="square" lIns="0" tIns="0" rIns="0" bIns="0" rtlCol="0" anchor="ctr"/>
+          <a:lstStyle/>
+          <a:p>
+            <a:pPr indent="0" marL="0">
+              <a:buNone/>
+            </a:pPr>
+            <a:r>
+              <a:rPr lang="en-US" sz="1400" dirty="0">
+                <a:solidFill>
+                  <a:srgbClr val="E9B872"/>
+                </a:solidFill>
+                <a:latin typeface="Calibri" pitchFamily="34" charset="0"/>
+                <a:ea typeface="Calibri" pitchFamily="34" charset="-122"/>
+                <a:cs typeface="Calibri" pitchFamily="34" charset="-120"/>
+              </a:rPr>
+              <a:t>English</a:t>
+            </a:r>
+            <a:endParaRPr lang="en-US" sz="1400" dirty="0"/>
+          </a:p>
+        </p:txBody>
+      </p:sp>
+    </p:spTree>
+  </p:cSld>
+  <p:clrMapOvr>
+    <a:masterClrMapping/>
+  </p:clrMapOvr>
+</p:sld>
+</file>
+
+<file path=ppt/slides/slide10.xml><?xml version="1.0" encoding="utf-8"?>
+<p:sld xmlns:a="http://schemas.openxmlformats.org/drawingml/2006/main" xmlns:r="http://schemas.openxmlformats.org/officeDocument/2006/relationships" xmlns:p="http://schemas.openxmlformats.org/presentationml/2006/main">
+  <p:cSld name="Slide 10">
+    <p:bg>
+      <p:bgPr>
+        <a:solidFill>
+          <a:srgbClr val="FFFFFF"/>
+        </a:solidFill>
+      </p:bgPr>
+    </p:bg>
+    <p:spTree>
+      <p:nvGrpSpPr>
+        <p:cNvPr id="1" name=""/>
+        <p:cNvGrpSpPr/>
+        <p:nvPr/>
+      </p:nvGrpSpPr>
+      <p:grpSpPr>
+        <a:xfrm>
+          <a:off x="0" y="0"/>
+          <a:ext cx="0" cy="0"/>
+          <a:chOff x="0" y="0"/>
+          <a:chExt cx="0" cy="0"/>
+        </a:xfrm>
+      </p:grpSpPr>
+      <p:sp>
+        <p:nvSpPr>
+          <p:cNvPr id="2" name="Text 0"/>
+          <p:cNvSpPr txBox="1"/>
+          <p:nvPr/>
+        </p:nvSpPr>
+        <p:spPr>
+          <a:xfrm>
+            <a:off x="457200" y="320040"/>
+            <a:ext cx="8229600" cy="731520"/>
+          </a:xfrm>
+          <a:prstGeom prst="rect">
+            <a:avLst/>
+          </a:prstGeom>
+          <a:noFill/>
+          <a:ln/>
+        </p:spPr>
+        <p:txBody>
+          <a:bodyPr wrap="square" lIns="0" tIns="0" rIns="0" bIns="0" rtlCol="0" anchor="ctr"/>
+          <a:lstStyle/>
+          <a:p>
+            <a:pPr indent="0" marL="0">
+              <a:buNone/>
+            </a:pPr>
+            <a:r>
+              <a:rPr lang="en-US" sz="3400" b="1" dirty="0">
+                <a:solidFill>
+                  <a:srgbClr val="6F2C4E"/>
+                </a:solidFill>
+                <a:latin typeface="Cambria" pitchFamily="34" charset="0"/>
+                <a:ea typeface="Cambria" pitchFamily="34" charset="-122"/>
+                <a:cs typeface="Cambria" pitchFamily="34" charset="-120"/>
+              </a:rPr>
+              <a:t>Ka hor maalinta furitaanka</a:t>
+            </a:r>
+            <a:endParaRPr lang="en-US" sz="3400" dirty="0"/>
+          </a:p>
+        </p:txBody>
+      </p:sp>
+      <p:sp>
+        <p:nvSpPr>
+          <p:cNvPr id="3" name="Shape 1"/>
+          <p:cNvSpPr/>
+          <p:nvPr/>
+        </p:nvSpPr>
+        <p:spPr>
+          <a:xfrm>
+            <a:off x="457200" y="1280160"/>
+            <a:ext cx="4023360" cy="1554480"/>
+          </a:xfrm>
+          <a:prstGeom prst="roundRect">
+            <a:avLst>
+              <a:gd name="adj" fmla="val 4706"/>
+            </a:avLst>
+          </a:prstGeom>
+          <a:solidFill>
+            <a:srgbClr val="F6EBF1"/>
+          </a:solidFill>
+          <a:ln w="12700">
+            <a:solidFill>
+              <a:srgbClr val="F6EBF1"/>
+            </a:solidFill>
+            <a:prstDash val="solid"/>
+          </a:ln>
+        </p:spPr>
+      </p:sp>
+      <p:sp>
+        <p:nvSpPr>
+          <p:cNvPr id="4" name="Text 2"/>
+          <p:cNvSpPr txBox="1"/>
+          <p:nvPr/>
+        </p:nvSpPr>
+        <p:spPr>
+          <a:xfrm>
+            <a:off x="685800" y="1417320"/>
+            <a:ext cx="3566160" cy="411480"/>
+          </a:xfrm>
+          <a:prstGeom prst="rect">
+            <a:avLst/>
+          </a:prstGeom>
+          <a:noFill/>
+          <a:ln/>
+        </p:spPr>
+        <p:txBody>
+          <a:bodyPr wrap="square" lIns="0" tIns="0" rIns="0" bIns="0" rtlCol="0" anchor="ctr"/>
+          <a:lstStyle/>
+          <a:p>
+            <a:pPr indent="0" marL="0">
+              <a:buNone/>
+            </a:pPr>
+            <a:r>
+              <a:rPr lang="en-US" sz="1800" b="1" dirty="0">
+                <a:solidFill>
+                  <a:srgbClr val="6F2C4E"/>
+                </a:solidFill>
+                <a:latin typeface="Calibri" pitchFamily="34" charset="0"/>
+                <a:ea typeface="Calibri" pitchFamily="34" charset="-122"/>
+                <a:cs typeface="Calibri" pitchFamily="34" charset="-120"/>
+              </a:rPr>
+              <a:t>Server leh HTTPS</a:t>
+            </a:r>
+            <a:endParaRPr lang="en-US" sz="1800" dirty="0"/>
+          </a:p>
+        </p:txBody>
+      </p:sp>
+      <p:sp>
+        <p:nvSpPr>
+          <p:cNvPr id="5" name="Text 3"/>
+          <p:cNvSpPr txBox="1"/>
+          <p:nvPr/>
+        </p:nvSpPr>
+        <p:spPr>
+          <a:xfrm>
+            <a:off x="685800" y="1920240"/>
+            <a:ext cx="3566160" cy="777240"/>
+          </a:xfrm>
+          <a:prstGeom prst="rect">
+            <a:avLst/>
+          </a:prstGeom>
+          <a:noFill/>
+          <a:ln/>
+        </p:spPr>
+        <p:txBody>
+          <a:bodyPr wrap="square" lIns="0" tIns="0" rIns="0" bIns="0" rtlCol="0" anchor="t"/>
+          <a:lstStyle/>
+          <a:p>
+            <a:pPr indent="0" marL="0">
+              <a:buNone/>
+            </a:pPr>
+            <a:r>
+              <a:rPr lang="en-US" sz="1600" dirty="0">
+                <a:solidFill>
+                  <a:srgbClr val="1F2933"/>
+                </a:solidFill>
+                <a:latin typeface="Calibri" pitchFamily="34" charset="0"/>
+                <a:ea typeface="Calibri" pitchFamily="34" charset="-122"/>
+                <a:cs typeface="Calibri" pitchFamily="34" charset="-120"/>
+              </a:rPr>
+              <a:t>Qofka IT-gaaga ayaa dejiya; tallaabooyinka waa la qoray</a:t>
+            </a:r>
+            <a:endParaRPr lang="en-US" sz="1600" dirty="0"/>
+          </a:p>
+        </p:txBody>
+      </p:sp>
+      <p:sp>
+        <p:nvSpPr>
+          <p:cNvPr id="6" name="Shape 4"/>
+          <p:cNvSpPr/>
+          <p:nvPr/>
+        </p:nvSpPr>
+        <p:spPr>
+          <a:xfrm>
+            <a:off x="4663440" y="1280160"/>
+            <a:ext cx="4023360" cy="1554480"/>
+          </a:xfrm>
+          <a:prstGeom prst="roundRect">
+            <a:avLst>
+              <a:gd name="adj" fmla="val 4706"/>
+            </a:avLst>
+          </a:prstGeom>
+          <a:solidFill>
+            <a:srgbClr val="F6EBF1"/>
+          </a:solidFill>
+          <a:ln w="12700">
+            <a:solidFill>
+              <a:srgbClr val="F6EBF1"/>
+            </a:solidFill>
+            <a:prstDash val="solid"/>
+          </a:ln>
+        </p:spPr>
+      </p:sp>
+      <p:sp>
+        <p:nvSpPr>
+          <p:cNvPr id="7" name="Text 5"/>
+          <p:cNvSpPr txBox="1"/>
+          <p:nvPr/>
+        </p:nvSpPr>
+        <p:spPr>
+          <a:xfrm>
+            <a:off x="4892040" y="1417320"/>
+            <a:ext cx="3566160" cy="411480"/>
+          </a:xfrm>
+          <a:prstGeom prst="rect">
+            <a:avLst/>
+          </a:prstGeom>
+          <a:noFill/>
+          <a:ln/>
+        </p:spPr>
+        <p:txBody>
+          <a:bodyPr wrap="square" lIns="0" tIns="0" rIns="0" bIns="0" rtlCol="0" anchor="ctr"/>
+          <a:lstStyle/>
+          <a:p>
+            <a:pPr indent="0" marL="0">
+              <a:buNone/>
+            </a:pPr>
+            <a:r>
+              <a:rPr lang="en-US" sz="1800" b="1" dirty="0">
+                <a:solidFill>
+                  <a:srgbClr val="6F2C4E"/>
+                </a:solidFill>
+                <a:latin typeface="Calibri" pitchFamily="34" charset="0"/>
+                <a:ea typeface="Calibri" pitchFamily="34" charset="-122"/>
+                <a:cs typeface="Calibri" pitchFamily="34" charset="-120"/>
+              </a:rPr>
+              <a:t>Iimayl iyo SMS</a:t>
+            </a:r>
+            <a:endParaRPr lang="en-US" sz="1800" dirty="0"/>
+          </a:p>
+        </p:txBody>
+      </p:sp>
+      <p:sp>
+        <p:nvSpPr>
+          <p:cNvPr id="8" name="Text 6"/>
+          <p:cNvSpPr txBox="1"/>
+          <p:nvPr/>
+        </p:nvSpPr>
+        <p:spPr>
+          <a:xfrm>
+            <a:off x="4892040" y="1920240"/>
+            <a:ext cx="3566160" cy="777240"/>
+          </a:xfrm>
+          <a:prstGeom prst="rect">
+            <a:avLst/>
+          </a:prstGeom>
+          <a:noFill/>
+          <a:ln/>
+        </p:spPr>
+        <p:txBody>
+          <a:bodyPr wrap="square" lIns="0" tIns="0" rIns="0" bIns="0" rtlCol="0" anchor="t"/>
+          <a:lstStyle/>
+          <a:p>
+            <a:pPr indent="0" marL="0">
+              <a:buNone/>
+            </a:pPr>
+            <a:r>
+              <a:rPr lang="en-US" sz="1600" dirty="0">
+                <a:solidFill>
+                  <a:srgbClr val="1F2933"/>
+                </a:solidFill>
+                <a:latin typeface="Calibri" pitchFamily="34" charset="0"/>
+                <a:ea typeface="Calibri" pitchFamily="34" charset="-122"/>
+                <a:cs typeface="Calibri" pitchFamily="34" charset="-120"/>
+              </a:rPr>
+              <a:t>Iimayluhu wuxuu u baahan yahay akoonkaaga iimaylka; fariimaha qoraalka weli lama gaarsiiyo</a:t>
+            </a:r>
+            <a:endParaRPr lang="en-US" sz="1600" dirty="0"/>
+          </a:p>
+        </p:txBody>
+      </p:sp>
+      <p:sp>
+        <p:nvSpPr>
+          <p:cNvPr id="9" name="Shape 7"/>
+          <p:cNvSpPr/>
+          <p:nvPr/>
+        </p:nvSpPr>
+        <p:spPr>
+          <a:xfrm>
+            <a:off x="457200" y="3017520"/>
+            <a:ext cx="4023360" cy="1554480"/>
+          </a:xfrm>
+          <a:prstGeom prst="roundRect">
+            <a:avLst>
+              <a:gd name="adj" fmla="val 4706"/>
+            </a:avLst>
+          </a:prstGeom>
+          <a:solidFill>
+            <a:srgbClr val="F6EBF1"/>
+          </a:solidFill>
+          <a:ln w="12700">
+            <a:solidFill>
+              <a:srgbClr val="F6EBF1"/>
+            </a:solidFill>
+            <a:prstDash val="solid"/>
+          </a:ln>
+        </p:spPr>
+      </p:sp>
+      <p:sp>
+        <p:nvSpPr>
+          <p:cNvPr id="10" name="Text 8"/>
+          <p:cNvSpPr txBox="1"/>
+          <p:nvPr/>
+        </p:nvSpPr>
+        <p:spPr>
+          <a:xfrm>
+            <a:off x="685800" y="3154680"/>
+            <a:ext cx="3566160" cy="411480"/>
+          </a:xfrm>
+          <a:prstGeom prst="rect">
+            <a:avLst/>
+          </a:prstGeom>
+          <a:noFill/>
+          <a:ln/>
+        </p:spPr>
+        <p:txBody>
+          <a:bodyPr wrap="square" lIns="0" tIns="0" rIns="0" bIns="0" rtlCol="0" anchor="ctr"/>
+          <a:lstStyle/>
+          <a:p>
+            <a:pPr indent="0" marL="0">
+              <a:buNone/>
+            </a:pPr>
+            <a:r>
+              <a:rPr lang="en-US" sz="1800" b="1" dirty="0">
+                <a:solidFill>
+                  <a:srgbClr val="6F2C4E"/>
+                </a:solidFill>
+                <a:latin typeface="Calibri" pitchFamily="34" charset="0"/>
+                <a:ea typeface="Calibri" pitchFamily="34" charset="-122"/>
+                <a:cs typeface="Calibri" pitchFamily="34" charset="-120"/>
+              </a:rPr>
+              <a:t>Kayd maalinle ah</a:t>
+            </a:r>
+            <a:endParaRPr lang="en-US" sz="1800" dirty="0"/>
+          </a:p>
+        </p:txBody>
+      </p:sp>
+      <p:sp>
+        <p:nvSpPr>
+          <p:cNvPr id="11" name="Text 9"/>
+          <p:cNvSpPr txBox="1"/>
+          <p:nvPr/>
+        </p:nvSpPr>
+        <p:spPr>
+          <a:xfrm>
+            <a:off x="685800" y="3657600"/>
+            <a:ext cx="3566160" cy="777240"/>
+          </a:xfrm>
+          <a:prstGeom prst="rect">
+            <a:avLst/>
+          </a:prstGeom>
+          <a:noFill/>
+          <a:ln/>
+        </p:spPr>
+        <p:txBody>
+          <a:bodyPr wrap="square" lIns="0" tIns="0" rIns="0" bIns="0" rtlCol="0" anchor="t"/>
+          <a:lstStyle/>
+          <a:p>
+            <a:pPr indent="0" marL="0">
+              <a:buNone/>
+            </a:pPr>
+            <a:r>
+              <a:rPr lang="en-US" sz="1600" dirty="0">
+                <a:solidFill>
+                  <a:srgbClr val="1F2933"/>
+                </a:solidFill>
+                <a:latin typeface="Calibri" pitchFamily="34" charset="0"/>
+                <a:ea typeface="Calibri" pitchFamily="34" charset="-122"/>
+                <a:cs typeface="Calibri" pitchFamily="34" charset="-120"/>
+              </a:rPr>
+              <a:t>U koobiyee meel labaad, oo tijaabi hal soo celin</a:t>
+            </a:r>
+            <a:endParaRPr lang="en-US" sz="1600" dirty="0"/>
+          </a:p>
+        </p:txBody>
+      </p:sp>
+      <p:sp>
+        <p:nvSpPr>
+          <p:cNvPr id="12" name="Shape 10"/>
+          <p:cNvSpPr/>
+          <p:nvPr/>
+        </p:nvSpPr>
+        <p:spPr>
+          <a:xfrm>
+            <a:off x="4663440" y="3017520"/>
+            <a:ext cx="4023360" cy="1554480"/>
+          </a:xfrm>
+          <a:prstGeom prst="roundRect">
+            <a:avLst>
+              <a:gd name="adj" fmla="val 4706"/>
+            </a:avLst>
+          </a:prstGeom>
+          <a:solidFill>
+            <a:srgbClr val="F6EBF1"/>
+          </a:solidFill>
+          <a:ln w="12700">
+            <a:solidFill>
+              <a:srgbClr val="F6EBF1"/>
+            </a:solidFill>
+            <a:prstDash val="solid"/>
+          </a:ln>
+        </p:spPr>
+      </p:sp>
+      <p:sp>
+        <p:nvSpPr>
+          <p:cNvPr id="13" name="Text 11"/>
+          <p:cNvSpPr txBox="1"/>
+          <p:nvPr/>
+        </p:nvSpPr>
+        <p:spPr>
+          <a:xfrm>
+            <a:off x="4892040" y="3154680"/>
+            <a:ext cx="3566160" cy="411480"/>
+          </a:xfrm>
+          <a:prstGeom prst="rect">
+            <a:avLst/>
+          </a:prstGeom>
+          <a:noFill/>
+          <a:ln/>
+        </p:spPr>
+        <p:txBody>
+          <a:bodyPr wrap="square" lIns="0" tIns="0" rIns="0" bIns="0" rtlCol="0" anchor="ctr"/>
+          <a:lstStyle/>
+          <a:p>
+            <a:pPr indent="0" marL="0">
+              <a:buNone/>
+            </a:pPr>
+            <a:r>
+              <a:rPr lang="en-US" sz="1800" b="1" dirty="0">
+                <a:solidFill>
+                  <a:srgbClr val="6F2C4E"/>
+                </a:solidFill>
+                <a:latin typeface="Calibri" pitchFamily="34" charset="0"/>
+                <a:ea typeface="Calibri" pitchFamily="34" charset="-122"/>
+                <a:cs typeface="Calibri" pitchFamily="34" charset="-120"/>
+              </a:rPr>
+              <a:t>Toddobaad tijaabo</a:t>
+            </a:r>
+            <a:endParaRPr lang="en-US" sz="1800" dirty="0"/>
+          </a:p>
+        </p:txBody>
+      </p:sp>
+      <p:sp>
+        <p:nvSpPr>
+          <p:cNvPr id="14" name="Text 12"/>
+          <p:cNvSpPr txBox="1"/>
+          <p:nvPr/>
+        </p:nvSpPr>
+        <p:spPr>
+          <a:xfrm>
+            <a:off x="4892040" y="3657600"/>
+            <a:ext cx="3566160" cy="777240"/>
+          </a:xfrm>
+          <a:prstGeom prst="rect">
+            <a:avLst/>
+          </a:prstGeom>
+          <a:noFill/>
+          <a:ln/>
+        </p:spPr>
+        <p:txBody>
+          <a:bodyPr wrap="square" lIns="0" tIns="0" rIns="0" bIns="0" rtlCol="0" anchor="t"/>
+          <a:lstStyle/>
+          <a:p>
+            <a:pPr indent="0" marL="0">
+              <a:buNone/>
+            </a:pPr>
+            <a:r>
+              <a:rPr lang="en-US" sz="1600" dirty="0">
+                <a:solidFill>
+                  <a:srgbClr val="1F2933"/>
+                </a:solidFill>
+                <a:latin typeface="Calibri" pitchFamily="34" charset="0"/>
+                <a:ea typeface="Calibri" pitchFamily="34" charset="-122"/>
+                <a:cs typeface="Calibri" pitchFamily="34" charset="-120"/>
+              </a:rPr>
+              <a:t>La socodsii nidaamka warqadaha ka hor inta aanad beddelin</a:t>
+            </a:r>
+            <a:endParaRPr lang="en-US" sz="1600" dirty="0"/>
           </a:p>
         </p:txBody>
       </p:sp>
@@ -2343,7 +3318,7 @@
         <p:spPr>
           <a:xfrm>
             <a:off x="457200" y="2560320"/>
-            <a:ext cx="2560320" cy="1097280"/>
+            <a:ext cx="2560320" cy="1188720"/>
           </a:xfrm>
           <a:prstGeom prst="rect">
             <a:avLst/>
@@ -2421,7 +3396,7 @@
         <p:spPr>
           <a:xfrm>
             <a:off x="3291840" y="2560320"/>
-            <a:ext cx="2560320" cy="1097280"/>
+            <a:ext cx="2560320" cy="1188720"/>
           </a:xfrm>
           <a:prstGeom prst="rect">
             <a:avLst/>
@@ -2499,7 +3474,7 @@
         <p:spPr>
           <a:xfrm>
             <a:off x="6126480" y="2560320"/>
-            <a:ext cx="2560320" cy="1097280"/>
+            <a:ext cx="2560320" cy="1188720"/>
           </a:xfrm>
           <a:prstGeom prst="rect">
             <a:avLst/>
@@ -3056,6 +4031,1414 @@
               <a:t>Run it alongside your paper system before switching</a:t>
             </a:r>
             <a:endParaRPr lang="en-US" sz="1600" dirty="0"/>
+          </a:p>
+        </p:txBody>
+      </p:sp>
+    </p:spTree>
+  </p:cSld>
+  <p:clrMapOvr>
+    <a:masterClrMapping/>
+  </p:clrMapOvr>
+</p:sld>
+</file>
+
+<file path=ppt/slides/slide6.xml><?xml version="1.0" encoding="utf-8"?>
+<p:sld xmlns:a="http://schemas.openxmlformats.org/drawingml/2006/main" xmlns:r="http://schemas.openxmlformats.org/officeDocument/2006/relationships" xmlns:p="http://schemas.openxmlformats.org/presentationml/2006/main">
+  <p:cSld name="Slide 6">
+    <p:bg>
+      <p:bgPr>
+        <a:solidFill>
+          <a:srgbClr val="6F2C4E"/>
+        </a:solidFill>
+      </p:bgPr>
+    </p:bg>
+    <p:spTree>
+      <p:nvGrpSpPr>
+        <p:cNvPr id="1" name=""/>
+        <p:cNvGrpSpPr/>
+        <p:nvPr/>
+      </p:nvGrpSpPr>
+      <p:grpSpPr>
+        <a:xfrm>
+          <a:off x="0" y="0"/>
+          <a:ext cx="0" cy="0"/>
+          <a:chOff x="0" y="0"/>
+          <a:chExt cx="0" cy="0"/>
+        </a:xfrm>
+      </p:grpSpPr>
+      <p:sp>
+        <p:nvSpPr>
+          <p:cNvPr id="2" name="Text 0"/>
+          <p:cNvSpPr txBox="1"/>
+          <p:nvPr/>
+        </p:nvSpPr>
+        <p:spPr>
+          <a:xfrm>
+            <a:off x="640080" y="1463040"/>
+            <a:ext cx="7863840" cy="1005840"/>
+          </a:xfrm>
+          <a:prstGeom prst="rect">
+            <a:avLst/>
+          </a:prstGeom>
+          <a:noFill/>
+          <a:ln/>
+        </p:spPr>
+        <p:txBody>
+          <a:bodyPr wrap="square" lIns="0" tIns="0" rIns="0" bIns="0" rtlCol="0" anchor="ctr"/>
+          <a:lstStyle/>
+          <a:p>
+            <a:pPr indent="0" marL="0">
+              <a:buNone/>
+            </a:pPr>
+            <a:r>
+              <a:rPr lang="en-US" sz="4400" b="1" dirty="0">
+                <a:solidFill>
+                  <a:srgbClr val="FFFFFF"/>
+                </a:solidFill>
+                <a:latin typeface="Cambria" pitchFamily="34" charset="0"/>
+                <a:ea typeface="Cambria" pitchFamily="34" charset="-122"/>
+                <a:cs typeface="Cambria" pitchFamily="34" charset="-120"/>
+              </a:rPr>
+              <a:t>Nidaamkaaga salon-ka</a:t>
+            </a:r>
+            <a:endParaRPr lang="en-US" sz="4400" dirty="0"/>
+          </a:p>
+        </p:txBody>
+      </p:sp>
+      <p:sp>
+        <p:nvSpPr>
+          <p:cNvPr id="3" name="Text 1"/>
+          <p:cNvSpPr txBox="1"/>
+          <p:nvPr/>
+        </p:nvSpPr>
+        <p:spPr>
+          <a:xfrm>
+            <a:off x="640080" y="2651760"/>
+            <a:ext cx="7315200" cy="822960"/>
+          </a:xfrm>
+          <a:prstGeom prst="rect">
+            <a:avLst/>
+          </a:prstGeom>
+          <a:noFill/>
+          <a:ln/>
+        </p:spPr>
+        <p:txBody>
+          <a:bodyPr wrap="square" lIns="0" tIns="0" rIns="0" bIns="0" rtlCol="0" anchor="ctr"/>
+          <a:lstStyle/>
+          <a:p>
+            <a:pPr indent="0" marL="0">
+              <a:buNone/>
+            </a:pPr>
+            <a:r>
+              <a:rPr lang="en-US" sz="2000" dirty="0">
+                <a:solidFill>
+                  <a:srgbClr val="F0DCE7"/>
+                </a:solidFill>
+                <a:latin typeface="Calibri" pitchFamily="34" charset="0"/>
+                <a:ea typeface="Calibri" pitchFamily="34" charset="-122"/>
+                <a:cs typeface="Calibri" pitchFamily="34" charset="-120"/>
+              </a:rPr>
+              <a:t>Waxa uu qabto, haddii uu ammaan yahay, iyo waxa aad diyaarin laha ka hor maalinta furitaanka</a:t>
+            </a:r>
+            <a:endParaRPr lang="en-US" sz="2000" dirty="0"/>
+          </a:p>
+        </p:txBody>
+      </p:sp>
+      <p:sp>
+        <p:nvSpPr>
+          <p:cNvPr id="4" name="Text 2"/>
+          <p:cNvSpPr txBox="1"/>
+          <p:nvPr/>
+        </p:nvSpPr>
+        <p:spPr>
+          <a:xfrm>
+            <a:off x="640080" y="4297680"/>
+            <a:ext cx="3657600" cy="365760"/>
+          </a:xfrm>
+          <a:prstGeom prst="rect">
+            <a:avLst/>
+          </a:prstGeom>
+          <a:noFill/>
+          <a:ln/>
+        </p:spPr>
+        <p:txBody>
+          <a:bodyPr wrap="square" lIns="0" tIns="0" rIns="0" bIns="0" rtlCol="0" anchor="ctr"/>
+          <a:lstStyle/>
+          <a:p>
+            <a:pPr indent="0" marL="0">
+              <a:buNone/>
+            </a:pPr>
+            <a:r>
+              <a:rPr lang="en-US" sz="1400" dirty="0">
+                <a:solidFill>
+                  <a:srgbClr val="E9B872"/>
+                </a:solidFill>
+                <a:latin typeface="Calibri" pitchFamily="34" charset="0"/>
+                <a:ea typeface="Calibri" pitchFamily="34" charset="-122"/>
+                <a:cs typeface="Calibri" pitchFamily="34" charset="-120"/>
+              </a:rPr>
+              <a:t>Af-Soomaali</a:t>
+            </a:r>
+            <a:endParaRPr lang="en-US" sz="1400" dirty="0"/>
+          </a:p>
+        </p:txBody>
+      </p:sp>
+    </p:spTree>
+  </p:cSld>
+  <p:clrMapOvr>
+    <a:masterClrMapping/>
+  </p:clrMapOvr>
+</p:sld>
+</file>
+
+<file path=ppt/slides/slide7.xml><?xml version="1.0" encoding="utf-8"?>
+<p:sld xmlns:a="http://schemas.openxmlformats.org/drawingml/2006/main" xmlns:r="http://schemas.openxmlformats.org/officeDocument/2006/relationships" xmlns:p="http://schemas.openxmlformats.org/presentationml/2006/main">
+  <p:cSld name="Slide 7">
+    <p:bg>
+      <p:bgPr>
+        <a:solidFill>
+          <a:srgbClr val="FFFFFF"/>
+        </a:solidFill>
+      </p:bgPr>
+    </p:bg>
+    <p:spTree>
+      <p:nvGrpSpPr>
+        <p:cNvPr id="1" name=""/>
+        <p:cNvGrpSpPr/>
+        <p:nvPr/>
+      </p:nvGrpSpPr>
+      <p:grpSpPr>
+        <a:xfrm>
+          <a:off x="0" y="0"/>
+          <a:ext cx="0" cy="0"/>
+          <a:chOff x="0" y="0"/>
+          <a:chExt cx="0" cy="0"/>
+        </a:xfrm>
+      </p:grpSpPr>
+      <p:sp>
+        <p:nvSpPr>
+          <p:cNvPr id="2" name="Text 0"/>
+          <p:cNvSpPr txBox="1"/>
+          <p:nvPr/>
+        </p:nvSpPr>
+        <p:spPr>
+          <a:xfrm>
+            <a:off x="457200" y="320040"/>
+            <a:ext cx="8229600" cy="731520"/>
+          </a:xfrm>
+          <a:prstGeom prst="rect">
+            <a:avLst/>
+          </a:prstGeom>
+          <a:noFill/>
+          <a:ln/>
+        </p:spPr>
+        <p:txBody>
+          <a:bodyPr wrap="square" lIns="0" tIns="0" rIns="0" bIns="0" rtlCol="0" anchor="ctr"/>
+          <a:lstStyle/>
+          <a:p>
+            <a:pPr indent="0" marL="0">
+              <a:buNone/>
+            </a:pPr>
+            <a:r>
+              <a:rPr lang="en-US" sz="3400" b="1" dirty="0">
+                <a:solidFill>
+                  <a:srgbClr val="6F2C4E"/>
+                </a:solidFill>
+                <a:latin typeface="Cambria" pitchFamily="34" charset="0"/>
+                <a:ea typeface="Cambria" pitchFamily="34" charset="-122"/>
+                <a:cs typeface="Cambria" pitchFamily="34" charset="-120"/>
+              </a:rPr>
+              <a:t>Wax walba hal meel</a:t>
+            </a:r>
+            <a:endParaRPr lang="en-US" sz="3400" dirty="0"/>
+          </a:p>
+        </p:txBody>
+      </p:sp>
+      <p:sp>
+        <p:nvSpPr>
+          <p:cNvPr id="3" name="Shape 1"/>
+          <p:cNvSpPr/>
+          <p:nvPr/>
+        </p:nvSpPr>
+        <p:spPr>
+          <a:xfrm>
+            <a:off x="457200" y="1280160"/>
+            <a:ext cx="2606040" cy="1554480"/>
+          </a:xfrm>
+          <a:prstGeom prst="roundRect">
+            <a:avLst>
+              <a:gd name="adj" fmla="val 4706"/>
+            </a:avLst>
+          </a:prstGeom>
+          <a:solidFill>
+            <a:srgbClr val="F6EBF1"/>
+          </a:solidFill>
+          <a:ln w="12700">
+            <a:solidFill>
+              <a:srgbClr val="F6EBF1"/>
+            </a:solidFill>
+            <a:prstDash val="solid"/>
+          </a:ln>
+        </p:spPr>
+      </p:sp>
+      <p:sp>
+        <p:nvSpPr>
+          <p:cNvPr id="4" name="Text 2"/>
+          <p:cNvSpPr txBox="1"/>
+          <p:nvPr/>
+        </p:nvSpPr>
+        <p:spPr>
+          <a:xfrm>
+            <a:off x="685800" y="1417320"/>
+            <a:ext cx="2148840" cy="411480"/>
+          </a:xfrm>
+          <a:prstGeom prst="rect">
+            <a:avLst/>
+          </a:prstGeom>
+          <a:noFill/>
+          <a:ln/>
+        </p:spPr>
+        <p:txBody>
+          <a:bodyPr wrap="square" lIns="0" tIns="0" rIns="0" bIns="0" rtlCol="0" anchor="ctr"/>
+          <a:lstStyle/>
+          <a:p>
+            <a:pPr indent="0" marL="0">
+              <a:buNone/>
+            </a:pPr>
+            <a:r>
+              <a:rPr lang="en-US" sz="1800" b="1" dirty="0">
+                <a:solidFill>
+                  <a:srgbClr val="6F2C4E"/>
+                </a:solidFill>
+                <a:latin typeface="Calibri" pitchFamily="34" charset="0"/>
+                <a:ea typeface="Calibri" pitchFamily="34" charset="-122"/>
+                <a:cs typeface="Calibri" pitchFamily="34" charset="-120"/>
+              </a:rPr>
+              <a:t>Ballamaha</a:t>
+            </a:r>
+            <a:endParaRPr lang="en-US" sz="1800" dirty="0"/>
+          </a:p>
+        </p:txBody>
+      </p:sp>
+      <p:sp>
+        <p:nvSpPr>
+          <p:cNvPr id="5" name="Text 3"/>
+          <p:cNvSpPr txBox="1"/>
+          <p:nvPr/>
+        </p:nvSpPr>
+        <p:spPr>
+          <a:xfrm>
+            <a:off x="685800" y="1920240"/>
+            <a:ext cx="2148840" cy="777240"/>
+          </a:xfrm>
+          <a:prstGeom prst="rect">
+            <a:avLst/>
+          </a:prstGeom>
+          <a:noFill/>
+          <a:ln/>
+        </p:spPr>
+        <p:txBody>
+          <a:bodyPr wrap="square" lIns="0" tIns="0" rIns="0" bIns="0" rtlCol="0" anchor="t"/>
+          <a:lstStyle/>
+          <a:p>
+            <a:pPr indent="0" marL="0">
+              <a:buNone/>
+            </a:pPr>
+            <a:r>
+              <a:rPr lang="en-US" sz="1600" dirty="0">
+                <a:solidFill>
+                  <a:srgbClr val="1F2933"/>
+                </a:solidFill>
+                <a:latin typeface="Calibri" pitchFamily="34" charset="0"/>
+                <a:ea typeface="Calibri" pitchFamily="34" charset="-122"/>
+                <a:cs typeface="Calibri" pitchFamily="34" charset="-120"/>
+              </a:rPr>
+              <a:t>Jadwal ballamo oo aan labo ballan isku mar siin shaqaale</a:t>
+            </a:r>
+            <a:endParaRPr lang="en-US" sz="1600" dirty="0"/>
+          </a:p>
+        </p:txBody>
+      </p:sp>
+      <p:sp>
+        <p:nvSpPr>
+          <p:cNvPr id="6" name="Shape 4"/>
+          <p:cNvSpPr/>
+          <p:nvPr/>
+        </p:nvSpPr>
+        <p:spPr>
+          <a:xfrm>
+            <a:off x="3246120" y="1280160"/>
+            <a:ext cx="2606040" cy="1554480"/>
+          </a:xfrm>
+          <a:prstGeom prst="roundRect">
+            <a:avLst>
+              <a:gd name="adj" fmla="val 4706"/>
+            </a:avLst>
+          </a:prstGeom>
+          <a:solidFill>
+            <a:srgbClr val="F6EBF1"/>
+          </a:solidFill>
+          <a:ln w="12700">
+            <a:solidFill>
+              <a:srgbClr val="F6EBF1"/>
+            </a:solidFill>
+            <a:prstDash val="solid"/>
+          </a:ln>
+        </p:spPr>
+      </p:sp>
+      <p:sp>
+        <p:nvSpPr>
+          <p:cNvPr id="7" name="Text 5"/>
+          <p:cNvSpPr txBox="1"/>
+          <p:nvPr/>
+        </p:nvSpPr>
+        <p:spPr>
+          <a:xfrm>
+            <a:off x="3474720" y="1417320"/>
+            <a:ext cx="2148840" cy="411480"/>
+          </a:xfrm>
+          <a:prstGeom prst="rect">
+            <a:avLst/>
+          </a:prstGeom>
+          <a:noFill/>
+          <a:ln/>
+        </p:spPr>
+        <p:txBody>
+          <a:bodyPr wrap="square" lIns="0" tIns="0" rIns="0" bIns="0" rtlCol="0" anchor="ctr"/>
+          <a:lstStyle/>
+          <a:p>
+            <a:pPr indent="0" marL="0">
+              <a:buNone/>
+            </a:pPr>
+            <a:r>
+              <a:rPr lang="en-US" sz="1800" b="1" dirty="0">
+                <a:solidFill>
+                  <a:srgbClr val="6F2C4E"/>
+                </a:solidFill>
+                <a:latin typeface="Calibri" pitchFamily="34" charset="0"/>
+                <a:ea typeface="Calibri" pitchFamily="34" charset="-122"/>
+                <a:cs typeface="Calibri" pitchFamily="34" charset="-120"/>
+              </a:rPr>
+              <a:t>Iibka</a:t>
+            </a:r>
+            <a:endParaRPr lang="en-US" sz="1800" dirty="0"/>
+          </a:p>
+        </p:txBody>
+      </p:sp>
+      <p:sp>
+        <p:nvSpPr>
+          <p:cNvPr id="8" name="Text 6"/>
+          <p:cNvSpPr txBox="1"/>
+          <p:nvPr/>
+        </p:nvSpPr>
+        <p:spPr>
+          <a:xfrm>
+            <a:off x="3474720" y="1920240"/>
+            <a:ext cx="2148840" cy="777240"/>
+          </a:xfrm>
+          <a:prstGeom prst="rect">
+            <a:avLst/>
+          </a:prstGeom>
+          <a:noFill/>
+          <a:ln/>
+        </p:spPr>
+        <p:txBody>
+          <a:bodyPr wrap="square" lIns="0" tIns="0" rIns="0" bIns="0" rtlCol="0" anchor="t"/>
+          <a:lstStyle/>
+          <a:p>
+            <a:pPr indent="0" marL="0">
+              <a:buNone/>
+            </a:pPr>
+            <a:r>
+              <a:rPr lang="en-US" sz="1600" dirty="0">
+                <a:solidFill>
+                  <a:srgbClr val="1F2933"/>
+                </a:solidFill>
+                <a:latin typeface="Calibri" pitchFamily="34" charset="0"/>
+                <a:ea typeface="Calibri" pitchFamily="34" charset="-122"/>
+                <a:cs typeface="Calibri" pitchFamily="34" charset="-120"/>
+              </a:rPr>
+              <a:t>Sanduuq, bixin kala qaybsan, rasiidh, soo celin, tirinta maalinlaha</a:t>
+            </a:r>
+            <a:endParaRPr lang="en-US" sz="1600" dirty="0"/>
+          </a:p>
+        </p:txBody>
+      </p:sp>
+      <p:sp>
+        <p:nvSpPr>
+          <p:cNvPr id="9" name="Shape 7"/>
+          <p:cNvSpPr/>
+          <p:nvPr/>
+        </p:nvSpPr>
+        <p:spPr>
+          <a:xfrm>
+            <a:off x="6035040" y="1280160"/>
+            <a:ext cx="2606040" cy="1554480"/>
+          </a:xfrm>
+          <a:prstGeom prst="roundRect">
+            <a:avLst>
+              <a:gd name="adj" fmla="val 4706"/>
+            </a:avLst>
+          </a:prstGeom>
+          <a:solidFill>
+            <a:srgbClr val="F6EBF1"/>
+          </a:solidFill>
+          <a:ln w="12700">
+            <a:solidFill>
+              <a:srgbClr val="F6EBF1"/>
+            </a:solidFill>
+            <a:prstDash val="solid"/>
+          </a:ln>
+        </p:spPr>
+      </p:sp>
+      <p:sp>
+        <p:nvSpPr>
+          <p:cNvPr id="10" name="Text 8"/>
+          <p:cNvSpPr txBox="1"/>
+          <p:nvPr/>
+        </p:nvSpPr>
+        <p:spPr>
+          <a:xfrm>
+            <a:off x="6263640" y="1417320"/>
+            <a:ext cx="2148840" cy="411480"/>
+          </a:xfrm>
+          <a:prstGeom prst="rect">
+            <a:avLst/>
+          </a:prstGeom>
+          <a:noFill/>
+          <a:ln/>
+        </p:spPr>
+        <p:txBody>
+          <a:bodyPr wrap="square" lIns="0" tIns="0" rIns="0" bIns="0" rtlCol="0" anchor="ctr"/>
+          <a:lstStyle/>
+          <a:p>
+            <a:pPr indent="0" marL="0">
+              <a:buNone/>
+            </a:pPr>
+            <a:r>
+              <a:rPr lang="en-US" sz="1800" b="1" dirty="0">
+                <a:solidFill>
+                  <a:srgbClr val="6F2C4E"/>
+                </a:solidFill>
+                <a:latin typeface="Calibri" pitchFamily="34" charset="0"/>
+                <a:ea typeface="Calibri" pitchFamily="34" charset="-122"/>
+                <a:cs typeface="Calibri" pitchFamily="34" charset="-120"/>
+              </a:rPr>
+              <a:t>Kaydka</a:t>
+            </a:r>
+            <a:endParaRPr lang="en-US" sz="1800" dirty="0"/>
+          </a:p>
+        </p:txBody>
+      </p:sp>
+      <p:sp>
+        <p:nvSpPr>
+          <p:cNvPr id="11" name="Text 9"/>
+          <p:cNvSpPr txBox="1"/>
+          <p:nvPr/>
+        </p:nvSpPr>
+        <p:spPr>
+          <a:xfrm>
+            <a:off x="6263640" y="1920240"/>
+            <a:ext cx="2148840" cy="777240"/>
+          </a:xfrm>
+          <a:prstGeom prst="rect">
+            <a:avLst/>
+          </a:prstGeom>
+          <a:noFill/>
+          <a:ln/>
+        </p:spPr>
+        <p:txBody>
+          <a:bodyPr wrap="square" lIns="0" tIns="0" rIns="0" bIns="0" rtlCol="0" anchor="t"/>
+          <a:lstStyle/>
+          <a:p>
+            <a:pPr indent="0" marL="0">
+              <a:buNone/>
+            </a:pPr>
+            <a:r>
+              <a:rPr lang="en-US" sz="1600" dirty="0">
+                <a:solidFill>
+                  <a:srgbClr val="1F2933"/>
+                </a:solidFill>
+                <a:latin typeface="Calibri" pitchFamily="34" charset="0"/>
+                <a:ea typeface="Calibri" pitchFamily="34" charset="-122"/>
+                <a:cs typeface="Calibri" pitchFamily="34" charset="-120"/>
+              </a:rPr>
+              <a:t>Alaab, alaab-qeybiye iyo dalabyo; isbeddel kasta waa la diiwaangeliyaa</a:t>
+            </a:r>
+            <a:endParaRPr lang="en-US" sz="1600" dirty="0"/>
+          </a:p>
+        </p:txBody>
+      </p:sp>
+      <p:sp>
+        <p:nvSpPr>
+          <p:cNvPr id="12" name="Shape 10"/>
+          <p:cNvSpPr/>
+          <p:nvPr/>
+        </p:nvSpPr>
+        <p:spPr>
+          <a:xfrm>
+            <a:off x="457200" y="3017520"/>
+            <a:ext cx="2606040" cy="1554480"/>
+          </a:xfrm>
+          <a:prstGeom prst="roundRect">
+            <a:avLst>
+              <a:gd name="adj" fmla="val 4706"/>
+            </a:avLst>
+          </a:prstGeom>
+          <a:solidFill>
+            <a:srgbClr val="F6EBF1"/>
+          </a:solidFill>
+          <a:ln w="12700">
+            <a:solidFill>
+              <a:srgbClr val="F6EBF1"/>
+            </a:solidFill>
+            <a:prstDash val="solid"/>
+          </a:ln>
+        </p:spPr>
+      </p:sp>
+      <p:sp>
+        <p:nvSpPr>
+          <p:cNvPr id="13" name="Text 11"/>
+          <p:cNvSpPr txBox="1"/>
+          <p:nvPr/>
+        </p:nvSpPr>
+        <p:spPr>
+          <a:xfrm>
+            <a:off x="685800" y="3154680"/>
+            <a:ext cx="2148840" cy="411480"/>
+          </a:xfrm>
+          <a:prstGeom prst="rect">
+            <a:avLst/>
+          </a:prstGeom>
+          <a:noFill/>
+          <a:ln/>
+        </p:spPr>
+        <p:txBody>
+          <a:bodyPr wrap="square" lIns="0" tIns="0" rIns="0" bIns="0" rtlCol="0" anchor="ctr"/>
+          <a:lstStyle/>
+          <a:p>
+            <a:pPr indent="0" marL="0">
+              <a:buNone/>
+            </a:pPr>
+            <a:r>
+              <a:rPr lang="en-US" sz="1800" b="1" dirty="0">
+                <a:solidFill>
+                  <a:srgbClr val="6F2C4E"/>
+                </a:solidFill>
+                <a:latin typeface="Calibri" pitchFamily="34" charset="0"/>
+                <a:ea typeface="Calibri" pitchFamily="34" charset="-122"/>
+                <a:cs typeface="Calibri" pitchFamily="34" charset="-120"/>
+              </a:rPr>
+              <a:t>Shaqaalaha</a:t>
+            </a:r>
+            <a:endParaRPr lang="en-US" sz="1800" dirty="0"/>
+          </a:p>
+        </p:txBody>
+      </p:sp>
+      <p:sp>
+        <p:nvSpPr>
+          <p:cNvPr id="14" name="Text 12"/>
+          <p:cNvSpPr txBox="1"/>
+          <p:nvPr/>
+        </p:nvSpPr>
+        <p:spPr>
+          <a:xfrm>
+            <a:off x="685800" y="3657600"/>
+            <a:ext cx="2148840" cy="777240"/>
+          </a:xfrm>
+          <a:prstGeom prst="rect">
+            <a:avLst/>
+          </a:prstGeom>
+          <a:noFill/>
+          <a:ln/>
+        </p:spPr>
+        <p:txBody>
+          <a:bodyPr wrap="square" lIns="0" tIns="0" rIns="0" bIns="0" rtlCol="0" anchor="t"/>
+          <a:lstStyle/>
+          <a:p>
+            <a:pPr indent="0" marL="0">
+              <a:buNone/>
+            </a:pPr>
+            <a:r>
+              <a:rPr lang="en-US" sz="1600" dirty="0">
+                <a:solidFill>
+                  <a:srgbClr val="1F2933"/>
+                </a:solidFill>
+                <a:latin typeface="Calibri" pitchFamily="34" charset="0"/>
+                <a:ea typeface="Calibri" pitchFamily="34" charset="-122"/>
+                <a:cs typeface="Calibri" pitchFamily="34" charset="-120"/>
+              </a:rPr>
+              <a:t>Joogitaanka, fasaxa iyo komishanka oo leh xeerar cad</a:t>
+            </a:r>
+            <a:endParaRPr lang="en-US" sz="1600" dirty="0"/>
+          </a:p>
+        </p:txBody>
+      </p:sp>
+      <p:sp>
+        <p:nvSpPr>
+          <p:cNvPr id="15" name="Shape 13"/>
+          <p:cNvSpPr/>
+          <p:nvPr/>
+        </p:nvSpPr>
+        <p:spPr>
+          <a:xfrm>
+            <a:off x="3246120" y="3017520"/>
+            <a:ext cx="2606040" cy="1554480"/>
+          </a:xfrm>
+          <a:prstGeom prst="roundRect">
+            <a:avLst>
+              <a:gd name="adj" fmla="val 4706"/>
+            </a:avLst>
+          </a:prstGeom>
+          <a:solidFill>
+            <a:srgbClr val="F6EBF1"/>
+          </a:solidFill>
+          <a:ln w="12700">
+            <a:solidFill>
+              <a:srgbClr val="F6EBF1"/>
+            </a:solidFill>
+            <a:prstDash val="solid"/>
+          </a:ln>
+        </p:spPr>
+      </p:sp>
+      <p:sp>
+        <p:nvSpPr>
+          <p:cNvPr id="16" name="Text 14"/>
+          <p:cNvSpPr txBox="1"/>
+          <p:nvPr/>
+        </p:nvSpPr>
+        <p:spPr>
+          <a:xfrm>
+            <a:off x="3474720" y="3154680"/>
+            <a:ext cx="2148840" cy="411480"/>
+          </a:xfrm>
+          <a:prstGeom prst="rect">
+            <a:avLst/>
+          </a:prstGeom>
+          <a:noFill/>
+          <a:ln/>
+        </p:spPr>
+        <p:txBody>
+          <a:bodyPr wrap="square" lIns="0" tIns="0" rIns="0" bIns="0" rtlCol="0" anchor="ctr"/>
+          <a:lstStyle/>
+          <a:p>
+            <a:pPr indent="0" marL="0">
+              <a:buNone/>
+            </a:pPr>
+            <a:r>
+              <a:rPr lang="en-US" sz="1800" b="1" dirty="0">
+                <a:solidFill>
+                  <a:srgbClr val="6F2C4E"/>
+                </a:solidFill>
+                <a:latin typeface="Calibri" pitchFamily="34" charset="0"/>
+                <a:ea typeface="Calibri" pitchFamily="34" charset="-122"/>
+                <a:cs typeface="Calibri" pitchFamily="34" charset="-120"/>
+              </a:rPr>
+              <a:t>Macaamiisha</a:t>
+            </a:r>
+            <a:endParaRPr lang="en-US" sz="1800" dirty="0"/>
+          </a:p>
+        </p:txBody>
+      </p:sp>
+      <p:sp>
+        <p:nvSpPr>
+          <p:cNvPr id="17" name="Text 15"/>
+          <p:cNvSpPr txBox="1"/>
+          <p:nvPr/>
+        </p:nvSpPr>
+        <p:spPr>
+          <a:xfrm>
+            <a:off x="3474720" y="3657600"/>
+            <a:ext cx="2148840" cy="777240"/>
+          </a:xfrm>
+          <a:prstGeom prst="rect">
+            <a:avLst/>
+          </a:prstGeom>
+          <a:noFill/>
+          <a:ln/>
+        </p:spPr>
+        <p:txBody>
+          <a:bodyPr wrap="square" lIns="0" tIns="0" rIns="0" bIns="0" rtlCol="0" anchor="t"/>
+          <a:lstStyle/>
+          <a:p>
+            <a:pPr indent="0" marL="0">
+              <a:buNone/>
+            </a:pPr>
+            <a:r>
+              <a:rPr lang="en-US" sz="1600" dirty="0">
+                <a:solidFill>
+                  <a:srgbClr val="1F2933"/>
+                </a:solidFill>
+                <a:latin typeface="Calibri" pitchFamily="34" charset="0"/>
+                <a:ea typeface="Calibri" pitchFamily="34" charset="-122"/>
+                <a:cs typeface="Calibri" pitchFamily="34" charset="-120"/>
+              </a:rPr>
+              <a:t>Dhibcaha daacadnimada, xubinnimada, kuubanno iyo salaan dhalasho</a:t>
+            </a:r>
+            <a:endParaRPr lang="en-US" sz="1600" dirty="0"/>
+          </a:p>
+        </p:txBody>
+      </p:sp>
+      <p:sp>
+        <p:nvSpPr>
+          <p:cNvPr id="18" name="Shape 16"/>
+          <p:cNvSpPr/>
+          <p:nvPr/>
+        </p:nvSpPr>
+        <p:spPr>
+          <a:xfrm>
+            <a:off x="6035040" y="3017520"/>
+            <a:ext cx="2606040" cy="1554480"/>
+          </a:xfrm>
+          <a:prstGeom prst="roundRect">
+            <a:avLst>
+              <a:gd name="adj" fmla="val 4706"/>
+            </a:avLst>
+          </a:prstGeom>
+          <a:solidFill>
+            <a:srgbClr val="F6EBF1"/>
+          </a:solidFill>
+          <a:ln w="12700">
+            <a:solidFill>
+              <a:srgbClr val="F6EBF1"/>
+            </a:solidFill>
+            <a:prstDash val="solid"/>
+          </a:ln>
+        </p:spPr>
+      </p:sp>
+      <p:sp>
+        <p:nvSpPr>
+          <p:cNvPr id="19" name="Text 17"/>
+          <p:cNvSpPr txBox="1"/>
+          <p:nvPr/>
+        </p:nvSpPr>
+        <p:spPr>
+          <a:xfrm>
+            <a:off x="6263640" y="3154680"/>
+            <a:ext cx="2148840" cy="411480"/>
+          </a:xfrm>
+          <a:prstGeom prst="rect">
+            <a:avLst/>
+          </a:prstGeom>
+          <a:noFill/>
+          <a:ln/>
+        </p:spPr>
+        <p:txBody>
+          <a:bodyPr wrap="square" lIns="0" tIns="0" rIns="0" bIns="0" rtlCol="0" anchor="ctr"/>
+          <a:lstStyle/>
+          <a:p>
+            <a:pPr indent="0" marL="0">
+              <a:buNone/>
+            </a:pPr>
+            <a:r>
+              <a:rPr lang="en-US" sz="1800" b="1" dirty="0">
+                <a:solidFill>
+                  <a:srgbClr val="6F2C4E"/>
+                </a:solidFill>
+                <a:latin typeface="Calibri" pitchFamily="34" charset="0"/>
+                <a:ea typeface="Calibri" pitchFamily="34" charset="-122"/>
+                <a:cs typeface="Calibri" pitchFamily="34" charset="-120"/>
+              </a:rPr>
+              <a:t>Lacagta</a:t>
+            </a:r>
+            <a:endParaRPr lang="en-US" sz="1800" dirty="0"/>
+          </a:p>
+        </p:txBody>
+      </p:sp>
+      <p:sp>
+        <p:nvSpPr>
+          <p:cNvPr id="20" name="Text 18"/>
+          <p:cNvSpPr txBox="1"/>
+          <p:nvPr/>
+        </p:nvSpPr>
+        <p:spPr>
+          <a:xfrm>
+            <a:off x="6263640" y="3657600"/>
+            <a:ext cx="2148840" cy="777240"/>
+          </a:xfrm>
+          <a:prstGeom prst="rect">
+            <a:avLst/>
+          </a:prstGeom>
+          <a:noFill/>
+          <a:ln/>
+        </p:spPr>
+        <p:txBody>
+          <a:bodyPr wrap="square" lIns="0" tIns="0" rIns="0" bIns="0" rtlCol="0" anchor="t"/>
+          <a:lstStyle/>
+          <a:p>
+            <a:pPr indent="0" marL="0">
+              <a:buNone/>
+            </a:pPr>
+            <a:r>
+              <a:rPr lang="en-US" sz="1600" dirty="0">
+                <a:solidFill>
+                  <a:srgbClr val="1F2933"/>
+                </a:solidFill>
+                <a:latin typeface="Calibri" pitchFamily="34" charset="0"/>
+                <a:ea typeface="Calibri" pitchFamily="34" charset="-122"/>
+                <a:cs typeface="Calibri" pitchFamily="34" charset="-120"/>
+              </a:rPr>
+              <a:t>Kharashyo la ansixiyo, soo koobid faa'iido iyo 18 warbixin</a:t>
+            </a:r>
+            <a:endParaRPr lang="en-US" sz="1600" dirty="0"/>
+          </a:p>
+        </p:txBody>
+      </p:sp>
+    </p:spTree>
+  </p:cSld>
+  <p:clrMapOvr>
+    <a:masterClrMapping/>
+  </p:clrMapOvr>
+</p:sld>
+</file>
+
+<file path=ppt/slides/slide8.xml><?xml version="1.0" encoding="utf-8"?>
+<p:sld xmlns:a="http://schemas.openxmlformats.org/drawingml/2006/main" xmlns:r="http://schemas.openxmlformats.org/officeDocument/2006/relationships" xmlns:p="http://schemas.openxmlformats.org/presentationml/2006/main">
+  <p:cSld name="Slide 8">
+    <p:bg>
+      <p:bgPr>
+        <a:solidFill>
+          <a:srgbClr val="FFFFFF"/>
+        </a:solidFill>
+      </p:bgPr>
+    </p:bg>
+    <p:spTree>
+      <p:nvGrpSpPr>
+        <p:cNvPr id="1" name=""/>
+        <p:cNvGrpSpPr/>
+        <p:nvPr/>
+      </p:nvGrpSpPr>
+      <p:grpSpPr>
+        <a:xfrm>
+          <a:off x="0" y="0"/>
+          <a:ext cx="0" cy="0"/>
+          <a:chOff x="0" y="0"/>
+          <a:chExt cx="0" cy="0"/>
+        </a:xfrm>
+      </p:grpSpPr>
+      <p:sp>
+        <p:nvSpPr>
+          <p:cNvPr id="2" name="Text 0"/>
+          <p:cNvSpPr txBox="1"/>
+          <p:nvPr/>
+        </p:nvSpPr>
+        <p:spPr>
+          <a:xfrm>
+            <a:off x="457200" y="320040"/>
+            <a:ext cx="8229600" cy="731520"/>
+          </a:xfrm>
+          <a:prstGeom prst="rect">
+            <a:avLst/>
+          </a:prstGeom>
+          <a:noFill/>
+          <a:ln/>
+        </p:spPr>
+        <p:txBody>
+          <a:bodyPr wrap="square" lIns="0" tIns="0" rIns="0" bIns="0" rtlCol="0" anchor="ctr"/>
+          <a:lstStyle/>
+          <a:p>
+            <a:pPr indent="0" marL="0">
+              <a:buNone/>
+            </a:pPr>
+            <a:r>
+              <a:rPr lang="en-US" sz="3400" b="1" dirty="0">
+                <a:solidFill>
+                  <a:srgbClr val="6F2C4E"/>
+                </a:solidFill>
+                <a:latin typeface="Cambria" pitchFamily="34" charset="0"/>
+                <a:ea typeface="Cambria" pitchFamily="34" charset="-122"/>
+                <a:cs typeface="Cambria" pitchFamily="34" charset="-120"/>
+              </a:rPr>
+              <a:t>Arag sida maalintu u socoto</a:t>
+            </a:r>
+            <a:endParaRPr lang="en-US" sz="3400" dirty="0"/>
+          </a:p>
+        </p:txBody>
+      </p:sp>
+      <p:pic>
+        <p:nvPicPr>
+          <p:cNvPr id="3" name="Image 0" descr="dashboard.png">    </p:cNvPr>
+          <p:cNvPicPr>
+            <a:picLocks noChangeAspect="1"/>
+          </p:cNvPicPr>
+          <p:nvPr/>
+        </p:nvPicPr>
+        <p:blipFill>
+          <a:blip r:embed="rId1"/>
+          <a:srcRect l="0" r="0" t="0" b="0"/>
+          <a:stretch/>
+        </p:blipFill>
+        <p:spPr>
+          <a:xfrm>
+            <a:off x="457200" y="1188720"/>
+            <a:ext cx="3017520" cy="3566160"/>
+          </a:xfrm>
+          <a:prstGeom prst="rect">
+            <a:avLst/>
+          </a:prstGeom>
+        </p:spPr>
+      </p:pic>
+      <p:sp>
+        <p:nvSpPr>
+          <p:cNvPr id="4" name="Text 1"/>
+          <p:cNvSpPr txBox="1"/>
+          <p:nvPr/>
+        </p:nvSpPr>
+        <p:spPr>
+          <a:xfrm>
+            <a:off x="3840480" y="1371600"/>
+            <a:ext cx="4846320" cy="914400"/>
+          </a:xfrm>
+          <a:prstGeom prst="rect">
+            <a:avLst/>
+          </a:prstGeom>
+          <a:noFill/>
+          <a:ln/>
+        </p:spPr>
+        <p:txBody>
+          <a:bodyPr wrap="square" lIns="0" tIns="0" rIns="0" bIns="0" rtlCol="0" anchor="t"/>
+          <a:lstStyle/>
+          <a:p>
+            <a:pPr marL="342900" indent="-342900">
+              <a:buSzPct val="100000"/>
+              <a:buChar char="•"/>
+            </a:pPr>
+            <a:r>
+              <a:rPr lang="en-US" sz="2000" dirty="0">
+                <a:solidFill>
+                  <a:srgbClr val="1F2933"/>
+                </a:solidFill>
+                <a:latin typeface="Calibri" pitchFamily="34" charset="0"/>
+                <a:ea typeface="Calibri" pitchFamily="34" charset="-122"/>
+                <a:cs typeface="Calibri" pitchFamily="34" charset="-120"/>
+              </a:rPr>
+              <a:t>Iibka la sameeyay iyo lacagta runtii la helay waa la kala muujiyaa</a:t>
+            </a:r>
+            <a:endParaRPr lang="en-US" sz="2000" dirty="0"/>
+          </a:p>
+        </p:txBody>
+      </p:sp>
+      <p:sp>
+        <p:nvSpPr>
+          <p:cNvPr id="5" name="Text 2"/>
+          <p:cNvSpPr txBox="1"/>
+          <p:nvPr/>
+        </p:nvSpPr>
+        <p:spPr>
+          <a:xfrm>
+            <a:off x="3840480" y="2468880"/>
+            <a:ext cx="4846320" cy="914400"/>
+          </a:xfrm>
+          <a:prstGeom prst="rect">
+            <a:avLst/>
+          </a:prstGeom>
+          <a:noFill/>
+          <a:ln/>
+        </p:spPr>
+        <p:txBody>
+          <a:bodyPr wrap="square" lIns="0" tIns="0" rIns="0" bIns="0" rtlCol="0" anchor="t"/>
+          <a:lstStyle/>
+          <a:p>
+            <a:pPr marL="342900" indent="-342900">
+              <a:buSzPct val="100000"/>
+              <a:buChar char="•"/>
+            </a:pPr>
+            <a:r>
+              <a:rPr lang="en-US" sz="2000" dirty="0">
+                <a:solidFill>
+                  <a:srgbClr val="1F2933"/>
+                </a:solidFill>
+                <a:latin typeface="Calibri" pitchFamily="34" charset="0"/>
+                <a:ea typeface="Calibri" pitchFamily="34" charset="-122"/>
+                <a:cs typeface="Calibri" pitchFamily="34" charset="-120"/>
+              </a:rPr>
+              <a:t>Kharashyada iyo faa'iidada la qiyaasay muddo kasta</a:t>
+            </a:r>
+            <a:endParaRPr lang="en-US" sz="2000" dirty="0"/>
+          </a:p>
+        </p:txBody>
+      </p:sp>
+      <p:sp>
+        <p:nvSpPr>
+          <p:cNvPr id="6" name="Text 3"/>
+          <p:cNvSpPr txBox="1"/>
+          <p:nvPr/>
+        </p:nvSpPr>
+        <p:spPr>
+          <a:xfrm>
+            <a:off x="3840480" y="3566160"/>
+            <a:ext cx="4846320" cy="914400"/>
+          </a:xfrm>
+          <a:prstGeom prst="rect">
+            <a:avLst/>
+          </a:prstGeom>
+          <a:noFill/>
+          <a:ln/>
+        </p:spPr>
+        <p:txBody>
+          <a:bodyPr wrap="square" lIns="0" tIns="0" rIns="0" bIns="0" rtlCol="0" anchor="t"/>
+          <a:lstStyle/>
+          <a:p>
+            <a:pPr marL="342900" indent="-342900">
+              <a:buSzPct val="100000"/>
+              <a:buChar char="•"/>
+            </a:pPr>
+            <a:r>
+              <a:rPr lang="en-US" sz="2000" dirty="0">
+                <a:solidFill>
+                  <a:srgbClr val="1F2933"/>
+                </a:solidFill>
+                <a:latin typeface="Calibri" pitchFamily="34" charset="0"/>
+                <a:ea typeface="Calibri" pitchFamily="34" charset="-122"/>
+                <a:cs typeface="Calibri" pitchFamily="34" charset="-120"/>
+              </a:rPr>
+              <a:t>Shaqaaluhu wuxuu arkaa kaliya waxa doorkiisu ogolyahay</a:t>
+            </a:r>
+            <a:endParaRPr lang="en-US" sz="2000" dirty="0"/>
+          </a:p>
+        </p:txBody>
+      </p:sp>
+    </p:spTree>
+  </p:cSld>
+  <p:clrMapOvr>
+    <a:masterClrMapping/>
+  </p:clrMapOvr>
+</p:sld>
+</file>
+
+<file path=ppt/slides/slide9.xml><?xml version="1.0" encoding="utf-8"?>
+<p:sld xmlns:a="http://schemas.openxmlformats.org/drawingml/2006/main" xmlns:r="http://schemas.openxmlformats.org/officeDocument/2006/relationships" xmlns:p="http://schemas.openxmlformats.org/presentationml/2006/main">
+  <p:cSld name="Slide 9">
+    <p:bg>
+      <p:bgPr>
+        <a:solidFill>
+          <a:srgbClr val="6F2C4E"/>
+        </a:solidFill>
+      </p:bgPr>
+    </p:bg>
+    <p:spTree>
+      <p:nvGrpSpPr>
+        <p:cNvPr id="1" name=""/>
+        <p:cNvGrpSpPr/>
+        <p:nvPr/>
+      </p:nvGrpSpPr>
+      <p:grpSpPr>
+        <a:xfrm>
+          <a:off x="0" y="0"/>
+          <a:ext cx="0" cy="0"/>
+          <a:chOff x="0" y="0"/>
+          <a:chExt cx="0" cy="0"/>
+        </a:xfrm>
+      </p:grpSpPr>
+      <p:sp>
+        <p:nvSpPr>
+          <p:cNvPr id="2" name="Text 0"/>
+          <p:cNvSpPr txBox="1"/>
+          <p:nvPr/>
+        </p:nvSpPr>
+        <p:spPr>
+          <a:xfrm>
+            <a:off x="457200" y="320040"/>
+            <a:ext cx="8229600" cy="731520"/>
+          </a:xfrm>
+          <a:prstGeom prst="rect">
+            <a:avLst/>
+          </a:prstGeom>
+          <a:noFill/>
+          <a:ln/>
+        </p:spPr>
+        <p:txBody>
+          <a:bodyPr wrap="square" lIns="0" tIns="0" rIns="0" bIns="0" rtlCol="0" anchor="ctr"/>
+          <a:lstStyle/>
+          <a:p>
+            <a:pPr indent="0" marL="0">
+              <a:buNone/>
+            </a:pPr>
+            <a:r>
+              <a:rPr lang="en-US" sz="3400" b="1" dirty="0">
+                <a:solidFill>
+                  <a:srgbClr val="FFFFFF"/>
+                </a:solidFill>
+                <a:latin typeface="Cambria" pitchFamily="34" charset="0"/>
+                <a:ea typeface="Cambria" pitchFamily="34" charset="-122"/>
+                <a:cs typeface="Cambria" pitchFamily="34" charset="-120"/>
+              </a:rPr>
+              <a:t>Ma lagu kalsoonaan karaa?</a:t>
+            </a:r>
+            <a:endParaRPr lang="en-US" sz="3400" dirty="0"/>
+          </a:p>
+        </p:txBody>
+      </p:sp>
+      <p:sp>
+        <p:nvSpPr>
+          <p:cNvPr id="3" name="Text 1"/>
+          <p:cNvSpPr txBox="1"/>
+          <p:nvPr/>
+        </p:nvSpPr>
+        <p:spPr>
+          <a:xfrm>
+            <a:off x="457200" y="1554480"/>
+            <a:ext cx="2560320" cy="914400"/>
+          </a:xfrm>
+          <a:prstGeom prst="rect">
+            <a:avLst/>
+          </a:prstGeom>
+          <a:noFill/>
+          <a:ln/>
+        </p:spPr>
+        <p:txBody>
+          <a:bodyPr wrap="square" lIns="0" tIns="0" rIns="0" bIns="0" rtlCol="0" anchor="ctr"/>
+          <a:lstStyle/>
+          <a:p>
+            <a:pPr indent="0" marL="0">
+              <a:buNone/>
+            </a:pPr>
+            <a:r>
+              <a:rPr lang="en-US" sz="5400" b="1" dirty="0">
+                <a:solidFill>
+                  <a:srgbClr val="E9B872"/>
+                </a:solidFill>
+                <a:latin typeface="Cambria" pitchFamily="34" charset="0"/>
+                <a:ea typeface="Cambria" pitchFamily="34" charset="-122"/>
+                <a:cs typeface="Cambria" pitchFamily="34" charset="-120"/>
+              </a:rPr>
+              <a:t>393</a:t>
+            </a:r>
+            <a:endParaRPr lang="en-US" sz="5400" dirty="0"/>
+          </a:p>
+        </p:txBody>
+      </p:sp>
+      <p:sp>
+        <p:nvSpPr>
+          <p:cNvPr id="4" name="Text 2"/>
+          <p:cNvSpPr txBox="1"/>
+          <p:nvPr/>
+        </p:nvSpPr>
+        <p:spPr>
+          <a:xfrm>
+            <a:off x="457200" y="2560320"/>
+            <a:ext cx="2560320" cy="1188720"/>
+          </a:xfrm>
+          <a:prstGeom prst="rect">
+            <a:avLst/>
+          </a:prstGeom>
+          <a:noFill/>
+          <a:ln/>
+        </p:spPr>
+        <p:txBody>
+          <a:bodyPr wrap="square" lIns="0" tIns="0" rIns="0" bIns="0" rtlCol="0" anchor="t"/>
+          <a:lstStyle/>
+          <a:p>
+            <a:pPr indent="0" marL="0">
+              <a:buNone/>
+            </a:pPr>
+            <a:r>
+              <a:rPr lang="en-US" sz="1800" dirty="0">
+                <a:solidFill>
+                  <a:srgbClr val="FFFFFF"/>
+                </a:solidFill>
+                <a:latin typeface="Calibri" pitchFamily="34" charset="0"/>
+                <a:ea typeface="Calibri" pitchFamily="34" charset="-122"/>
+                <a:cs typeface="Calibri" pitchFamily="34" charset="-120"/>
+              </a:rPr>
+              <a:t>hubin toos ah, dhammaantood way gudbeen</a:t>
+            </a:r>
+            <a:endParaRPr lang="en-US" sz="1800" dirty="0"/>
+          </a:p>
+        </p:txBody>
+      </p:sp>
+      <p:sp>
+        <p:nvSpPr>
+          <p:cNvPr id="5" name="Text 3"/>
+          <p:cNvSpPr txBox="1"/>
+          <p:nvPr/>
+        </p:nvSpPr>
+        <p:spPr>
+          <a:xfrm>
+            <a:off x="3291840" y="1554480"/>
+            <a:ext cx="2560320" cy="914400"/>
+          </a:xfrm>
+          <a:prstGeom prst="rect">
+            <a:avLst/>
+          </a:prstGeom>
+          <a:noFill/>
+          <a:ln/>
+        </p:spPr>
+        <p:txBody>
+          <a:bodyPr wrap="square" lIns="0" tIns="0" rIns="0" bIns="0" rtlCol="0" anchor="ctr"/>
+          <a:lstStyle/>
+          <a:p>
+            <a:pPr indent="0" marL="0">
+              <a:buNone/>
+            </a:pPr>
+            <a:r>
+              <a:rPr lang="en-US" sz="5400" b="1" dirty="0">
+                <a:solidFill>
+                  <a:srgbClr val="E9B872"/>
+                </a:solidFill>
+                <a:latin typeface="Cambria" pitchFamily="34" charset="0"/>
+                <a:ea typeface="Cambria" pitchFamily="34" charset="-122"/>
+                <a:cs typeface="Cambria" pitchFamily="34" charset="-120"/>
+              </a:rPr>
+              <a:t>10</a:t>
+            </a:r>
+            <a:endParaRPr lang="en-US" sz="5400" dirty="0"/>
+          </a:p>
+        </p:txBody>
+      </p:sp>
+      <p:sp>
+        <p:nvSpPr>
+          <p:cNvPr id="6" name="Text 4"/>
+          <p:cNvSpPr txBox="1"/>
+          <p:nvPr/>
+        </p:nvSpPr>
+        <p:spPr>
+          <a:xfrm>
+            <a:off x="3291840" y="2560320"/>
+            <a:ext cx="2560320" cy="1188720"/>
+          </a:xfrm>
+          <a:prstGeom prst="rect">
+            <a:avLst/>
+          </a:prstGeom>
+          <a:noFill/>
+          <a:ln/>
+        </p:spPr>
+        <p:txBody>
+          <a:bodyPr wrap="square" lIns="0" tIns="0" rIns="0" bIns="0" rtlCol="0" anchor="t"/>
+          <a:lstStyle/>
+          <a:p>
+            <a:pPr indent="0" marL="0">
+              <a:buNone/>
+            </a:pPr>
+            <a:r>
+              <a:rPr lang="en-US" sz="1800" dirty="0">
+                <a:solidFill>
+                  <a:srgbClr val="FFFFFF"/>
+                </a:solidFill>
+                <a:latin typeface="Calibri" pitchFamily="34" charset="0"/>
+                <a:ea typeface="Calibri" pitchFamily="34" charset="-122"/>
+                <a:cs typeface="Calibri" pitchFamily="34" charset="-120"/>
+              </a:rPr>
+              <a:t>khasnajiyayaal ku tartamaya shayga ugu dambeeya: hal iib oo keliya ayaa dhaafa</a:t>
+            </a:r>
+            <a:endParaRPr lang="en-US" sz="1800" dirty="0"/>
+          </a:p>
+        </p:txBody>
+      </p:sp>
+      <p:sp>
+        <p:nvSpPr>
+          <p:cNvPr id="7" name="Text 5"/>
+          <p:cNvSpPr txBox="1"/>
+          <p:nvPr/>
+        </p:nvSpPr>
+        <p:spPr>
+          <a:xfrm>
+            <a:off x="6126480" y="1554480"/>
+            <a:ext cx="2560320" cy="914400"/>
+          </a:xfrm>
+          <a:prstGeom prst="rect">
+            <a:avLst/>
+          </a:prstGeom>
+          <a:noFill/>
+          <a:ln/>
+        </p:spPr>
+        <p:txBody>
+          <a:bodyPr wrap="square" lIns="0" tIns="0" rIns="0" bIns="0" rtlCol="0" anchor="ctr"/>
+          <a:lstStyle/>
+          <a:p>
+            <a:pPr indent="0" marL="0">
+              <a:buNone/>
+            </a:pPr>
+            <a:r>
+              <a:rPr lang="en-US" sz="5400" b="1" dirty="0">
+                <a:solidFill>
+                  <a:srgbClr val="E9B872"/>
+                </a:solidFill>
+                <a:latin typeface="Cambria" pitchFamily="34" charset="0"/>
+                <a:ea typeface="Cambria" pitchFamily="34" charset="-122"/>
+                <a:cs typeface="Cambria" pitchFamily="34" charset="-120"/>
+              </a:rPr>
+              <a:t>1</a:t>
+            </a:r>
+            <a:endParaRPr lang="en-US" sz="5400" dirty="0"/>
+          </a:p>
+        </p:txBody>
+      </p:sp>
+      <p:sp>
+        <p:nvSpPr>
+          <p:cNvPr id="8" name="Text 6"/>
+          <p:cNvSpPr txBox="1"/>
+          <p:nvPr/>
+        </p:nvSpPr>
+        <p:spPr>
+          <a:xfrm>
+            <a:off x="6126480" y="2560320"/>
+            <a:ext cx="2560320" cy="1188720"/>
+          </a:xfrm>
+          <a:prstGeom prst="rect">
+            <a:avLst/>
+          </a:prstGeom>
+          <a:noFill/>
+          <a:ln/>
+        </p:spPr>
+        <p:txBody>
+          <a:bodyPr wrap="square" lIns="0" tIns="0" rIns="0" bIns="0" rtlCol="0" anchor="t"/>
+          <a:lstStyle/>
+          <a:p>
+            <a:pPr indent="0" marL="0">
+              <a:buNone/>
+            </a:pPr>
+            <a:r>
+              <a:rPr lang="en-US" sz="1800" dirty="0">
+                <a:solidFill>
+                  <a:srgbClr val="FFFFFF"/>
+                </a:solidFill>
+                <a:latin typeface="Calibri" pitchFamily="34" charset="0"/>
+                <a:ea typeface="Calibri" pitchFamily="34" charset="-122"/>
+                <a:cs typeface="Calibri" pitchFamily="34" charset="-120"/>
+              </a:rPr>
+              <a:t>kayd buuxa oo dib loo soo celiyay lana caddeeyay inuu shaqeeyo</a:t>
+            </a:r>
+            <a:endParaRPr lang="en-US" sz="1800" dirty="0"/>
+          </a:p>
+        </p:txBody>
+      </p:sp>
+      <p:sp>
+        <p:nvSpPr>
+          <p:cNvPr id="9" name="Text 7"/>
+          <p:cNvSpPr txBox="1"/>
+          <p:nvPr/>
+        </p:nvSpPr>
+        <p:spPr>
+          <a:xfrm>
+            <a:off x="457200" y="4023360"/>
+            <a:ext cx="8229600" cy="457200"/>
+          </a:xfrm>
+          <a:prstGeom prst="rect">
+            <a:avLst/>
+          </a:prstGeom>
+          <a:noFill/>
+          <a:ln/>
+        </p:spPr>
+        <p:txBody>
+          <a:bodyPr wrap="square" lIns="0" tIns="0" rIns="0" bIns="0" rtlCol="0" anchor="ctr"/>
+          <a:lstStyle/>
+          <a:p>
+            <a:pPr indent="0" marL="0">
+              <a:buNone/>
+            </a:pPr>
+            <a:r>
+              <a:rPr lang="en-US" sz="1800" dirty="0">
+                <a:solidFill>
+                  <a:srgbClr val="F0DCE7"/>
+                </a:solidFill>
+                <a:latin typeface="Calibri" pitchFamily="34" charset="0"/>
+                <a:ea typeface="Calibri" pitchFamily="34" charset="-122"/>
+                <a:cs typeface="Calibri" pitchFamily="34" charset="-120"/>
+              </a:rPr>
+              <a:t>Isbeddel lacageed kasta waa la diiwaangeliyaa lamana beddeli karo kadib.</a:t>
+            </a:r>
+            <a:endParaRPr lang="en-US" sz="1800" dirty="0"/>
           </a:p>
         </p:txBody>
       </p:sp>

</xml_diff>